<commit_message>
docs: add wrapped airplane and train svgs
Co-authored-by: Copilot <copilot@github.com>
</commit_message>
<xml_diff>
--- a/docs/train&aircraft icons/ppt canvas.pptx
+++ b/docs/train&aircraft icons/ppt canvas.pptx
@@ -7,6 +7,7 @@
   <p:sldIdLst>
     <p:sldId id="256" r:id="rId2"/>
     <p:sldId id="257" r:id="rId3"/>
+    <p:sldId id="258" r:id="rId4"/>
   </p:sldIdLst>
   <p:sldSz cx="12192000" cy="6858000"/>
   <p:notesSz cx="6858000" cy="9144000"/>
@@ -105,6 +106,11 @@
       </a:defRPr>
     </a:lvl9pPr>
   </p:defaultTextStyle>
+  <p:extLst>
+    <p:ext uri="{EFAFB233-063F-42B5-8137-9DF3F51BA10A}">
+      <p15:sldGuideLst xmlns:p15="http://schemas.microsoft.com/office/powerpoint/2012/main"/>
+    </p:ext>
+  </p:extLst>
 </p:presentation>
 </file>
 
@@ -257,7 +263,7 @@
           <a:p>
             <a:fld id="{3DD605E4-B377-4917-B1C5-44F5C855D813}" type="datetimeFigureOut">
               <a:rPr lang="zh-SG" altLang="en-US" smtClean="0"/>
-              <a:t>2/5/2026</a:t>
+              <a:t>3/5/2026</a:t>
             </a:fld>
             <a:endParaRPr lang="zh-SG" altLang="en-US"/>
           </a:p>
@@ -457,7 +463,7 @@
           <a:p>
             <a:fld id="{3DD605E4-B377-4917-B1C5-44F5C855D813}" type="datetimeFigureOut">
               <a:rPr lang="zh-SG" altLang="en-US" smtClean="0"/>
-              <a:t>2/5/2026</a:t>
+              <a:t>3/5/2026</a:t>
             </a:fld>
             <a:endParaRPr lang="zh-SG" altLang="en-US"/>
           </a:p>
@@ -667,7 +673,7 @@
           <a:p>
             <a:fld id="{3DD605E4-B377-4917-B1C5-44F5C855D813}" type="datetimeFigureOut">
               <a:rPr lang="zh-SG" altLang="en-US" smtClean="0"/>
-              <a:t>2/5/2026</a:t>
+              <a:t>3/5/2026</a:t>
             </a:fld>
             <a:endParaRPr lang="zh-SG" altLang="en-US"/>
           </a:p>
@@ -867,7 +873,7 @@
           <a:p>
             <a:fld id="{3DD605E4-B377-4917-B1C5-44F5C855D813}" type="datetimeFigureOut">
               <a:rPr lang="zh-SG" altLang="en-US" smtClean="0"/>
-              <a:t>2/5/2026</a:t>
+              <a:t>3/5/2026</a:t>
             </a:fld>
             <a:endParaRPr lang="zh-SG" altLang="en-US"/>
           </a:p>
@@ -1143,7 +1149,7 @@
           <a:p>
             <a:fld id="{3DD605E4-B377-4917-B1C5-44F5C855D813}" type="datetimeFigureOut">
               <a:rPr lang="zh-SG" altLang="en-US" smtClean="0"/>
-              <a:t>2/5/2026</a:t>
+              <a:t>3/5/2026</a:t>
             </a:fld>
             <a:endParaRPr lang="zh-SG" altLang="en-US"/>
           </a:p>
@@ -1411,7 +1417,7 @@
           <a:p>
             <a:fld id="{3DD605E4-B377-4917-B1C5-44F5C855D813}" type="datetimeFigureOut">
               <a:rPr lang="zh-SG" altLang="en-US" smtClean="0"/>
-              <a:t>2/5/2026</a:t>
+              <a:t>3/5/2026</a:t>
             </a:fld>
             <a:endParaRPr lang="zh-SG" altLang="en-US"/>
           </a:p>
@@ -1826,7 +1832,7 @@
           <a:p>
             <a:fld id="{3DD605E4-B377-4917-B1C5-44F5C855D813}" type="datetimeFigureOut">
               <a:rPr lang="zh-SG" altLang="en-US" smtClean="0"/>
-              <a:t>2/5/2026</a:t>
+              <a:t>3/5/2026</a:t>
             </a:fld>
             <a:endParaRPr lang="zh-SG" altLang="en-US"/>
           </a:p>
@@ -1968,7 +1974,7 @@
           <a:p>
             <a:fld id="{3DD605E4-B377-4917-B1C5-44F5C855D813}" type="datetimeFigureOut">
               <a:rPr lang="zh-SG" altLang="en-US" smtClean="0"/>
-              <a:t>2/5/2026</a:t>
+              <a:t>3/5/2026</a:t>
             </a:fld>
             <a:endParaRPr lang="zh-SG" altLang="en-US"/>
           </a:p>
@@ -2081,7 +2087,7 @@
           <a:p>
             <a:fld id="{3DD605E4-B377-4917-B1C5-44F5C855D813}" type="datetimeFigureOut">
               <a:rPr lang="zh-SG" altLang="en-US" smtClean="0"/>
-              <a:t>2/5/2026</a:t>
+              <a:t>3/5/2026</a:t>
             </a:fld>
             <a:endParaRPr lang="zh-SG" altLang="en-US"/>
           </a:p>
@@ -2394,7 +2400,7 @@
           <a:p>
             <a:fld id="{3DD605E4-B377-4917-B1C5-44F5C855D813}" type="datetimeFigureOut">
               <a:rPr lang="zh-SG" altLang="en-US" smtClean="0"/>
-              <a:t>2/5/2026</a:t>
+              <a:t>3/5/2026</a:t>
             </a:fld>
             <a:endParaRPr lang="zh-SG" altLang="en-US"/>
           </a:p>
@@ -2683,7 +2689,7 @@
           <a:p>
             <a:fld id="{3DD605E4-B377-4917-B1C5-44F5C855D813}" type="datetimeFigureOut">
               <a:rPr lang="zh-SG" altLang="en-US" smtClean="0"/>
-              <a:t>2/5/2026</a:t>
+              <a:t>3/5/2026</a:t>
             </a:fld>
             <a:endParaRPr lang="zh-SG" altLang="en-US"/>
           </a:p>
@@ -2926,7 +2932,7 @@
           <a:p>
             <a:fld id="{3DD605E4-B377-4917-B1C5-44F5C855D813}" type="datetimeFigureOut">
               <a:rPr lang="zh-SG" altLang="en-US" smtClean="0"/>
-              <a:t>2/5/2026</a:t>
+              <a:t>3/5/2026</a:t>
             </a:fld>
             <a:endParaRPr lang="zh-SG" altLang="en-US"/>
           </a:p>
@@ -3931,6 +3937,414 @@
 </p:sld>
 </file>
 
+<file path=ppt/slides/slide3.xml><?xml version="1.0" encoding="utf-8"?>
+<p:sld xmlns:a="http://schemas.openxmlformats.org/drawingml/2006/main" xmlns:r="http://schemas.openxmlformats.org/officeDocument/2006/relationships" xmlns:p="http://schemas.openxmlformats.org/presentationml/2006/main">
+  <p:cSld>
+    <p:spTree>
+      <p:nvGrpSpPr>
+        <p:cNvPr id="1" name="">
+          <a:extLst>
+            <a:ext uri="{FF2B5EF4-FFF2-40B4-BE49-F238E27FC236}">
+              <a16:creationId xmlns:a16="http://schemas.microsoft.com/office/drawing/2014/main" id="{24F47911-628A-0B7A-9CC5-E3CB31F5B6E1}"/>
+            </a:ext>
+          </a:extLst>
+        </p:cNvPr>
+        <p:cNvGrpSpPr/>
+        <p:nvPr/>
+      </p:nvGrpSpPr>
+      <p:grpSpPr>
+        <a:xfrm>
+          <a:off x="0" y="0"/>
+          <a:ext cx="0" cy="0"/>
+          <a:chOff x="0" y="0"/>
+          <a:chExt cx="0" cy="0"/>
+        </a:xfrm>
+      </p:grpSpPr>
+      <p:pic>
+        <p:nvPicPr>
+          <p:cNvPr id="5" name="图片 4">
+            <a:extLst>
+              <a:ext uri="{FF2B5EF4-FFF2-40B4-BE49-F238E27FC236}">
+                <a16:creationId xmlns:a16="http://schemas.microsoft.com/office/drawing/2014/main" id="{1242DF66-4A92-F717-DB71-D1B53D686B29}"/>
+              </a:ext>
+            </a:extLst>
+          </p:cNvPr>
+          <p:cNvPicPr>
+            <a:picLocks noChangeAspect="1"/>
+          </p:cNvPicPr>
+          <p:nvPr/>
+        </p:nvPicPr>
+        <p:blipFill>
+          <a:blip r:embed="rId2"/>
+          <a:stretch>
+            <a:fillRect/>
+          </a:stretch>
+        </p:blipFill>
+        <p:spPr>
+          <a:xfrm>
+            <a:off x="-412292" y="0"/>
+            <a:ext cx="7390163" cy="6858000"/>
+          </a:xfrm>
+          <a:prstGeom prst="rect">
+            <a:avLst/>
+          </a:prstGeom>
+        </p:spPr>
+      </p:pic>
+      <p:grpSp>
+        <p:nvGrpSpPr>
+          <p:cNvPr id="7" name="组合 6">
+            <a:extLst>
+              <a:ext uri="{FF2B5EF4-FFF2-40B4-BE49-F238E27FC236}">
+                <a16:creationId xmlns:a16="http://schemas.microsoft.com/office/drawing/2014/main" id="{8699AA0C-3AB9-878E-DBF3-807FFF7596BF}"/>
+              </a:ext>
+            </a:extLst>
+          </p:cNvPr>
+          <p:cNvGrpSpPr/>
+          <p:nvPr/>
+        </p:nvGrpSpPr>
+        <p:grpSpPr>
+          <a:xfrm>
+            <a:off x="1103383" y="1265274"/>
+            <a:ext cx="4527373" cy="4527373"/>
+            <a:chOff x="1103383" y="1265274"/>
+            <a:chExt cx="4527373" cy="4527373"/>
+          </a:xfrm>
+        </p:grpSpPr>
+        <p:sp>
+          <p:nvSpPr>
+            <p:cNvPr id="6" name="矩形: 圆角 5">
+              <a:extLst>
+                <a:ext uri="{FF2B5EF4-FFF2-40B4-BE49-F238E27FC236}">
+                  <a16:creationId xmlns:a16="http://schemas.microsoft.com/office/drawing/2014/main" id="{07DDF2D2-5FF1-8C3B-3281-C6F39D0E18C7}"/>
+                </a:ext>
+              </a:extLst>
+            </p:cNvPr>
+            <p:cNvSpPr/>
+            <p:nvPr/>
+          </p:nvSpPr>
+          <p:spPr>
+            <a:xfrm>
+              <a:off x="1103383" y="1265274"/>
+              <a:ext cx="4527373" cy="4527373"/>
+            </a:xfrm>
+            <a:prstGeom prst="roundRect">
+              <a:avLst>
+                <a:gd name="adj" fmla="val 10919"/>
+              </a:avLst>
+            </a:prstGeom>
+            <a:noFill/>
+            <a:ln w="190500">
+              <a:solidFill>
+                <a:schemeClr val="accent4"/>
+              </a:solidFill>
+            </a:ln>
+          </p:spPr>
+          <p:style>
+            <a:lnRef idx="2">
+              <a:schemeClr val="accent1">
+                <a:shade val="15000"/>
+              </a:schemeClr>
+            </a:lnRef>
+            <a:fillRef idx="1">
+              <a:schemeClr val="accent1"/>
+            </a:fillRef>
+            <a:effectRef idx="0">
+              <a:schemeClr val="accent1"/>
+            </a:effectRef>
+            <a:fontRef idx="minor">
+              <a:schemeClr val="lt1"/>
+            </a:fontRef>
+          </p:style>
+          <p:txBody>
+            <a:bodyPr rtlCol="0" anchor="ctr"/>
+            <a:lstStyle/>
+            <a:p>
+              <a:pPr algn="ctr"/>
+              <a:endParaRPr lang="zh-SG" altLang="en-US"/>
+            </a:p>
+          </p:txBody>
+        </p:sp>
+        <p:pic>
+          <p:nvPicPr>
+            <p:cNvPr id="8" name="图形 7">
+              <a:extLst>
+                <a:ext uri="{FF2B5EF4-FFF2-40B4-BE49-F238E27FC236}">
+                  <a16:creationId xmlns:a16="http://schemas.microsoft.com/office/drawing/2014/main" id="{D5E735D2-04D1-4674-04A7-DF795B2C3F66}"/>
+                </a:ext>
+              </a:extLst>
+            </p:cNvPr>
+            <p:cNvPicPr>
+              <a:picLocks noChangeAspect="1"/>
+            </p:cNvPicPr>
+            <p:nvPr/>
+          </p:nvPicPr>
+          <p:blipFill>
+            <a:blip>
+              <a:extLst>
+                <a:ext uri="{96DAC541-7B7A-43D3-8B79-37D633B846F1}">
+                  <asvg:svgBlip xmlns:asvg="http://schemas.microsoft.com/office/drawing/2016/SVG/main" r:embed="rId3"/>
+                </a:ext>
+              </a:extLst>
+            </a:blip>
+            <a:stretch>
+              <a:fillRect/>
+            </a:stretch>
+          </p:blipFill>
+          <p:spPr>
+            <a:xfrm>
+              <a:off x="1580909" y="1742800"/>
+              <a:ext cx="3572320" cy="3572320"/>
+            </a:xfrm>
+            <a:prstGeom prst="rect">
+              <a:avLst/>
+            </a:prstGeom>
+          </p:spPr>
+        </p:pic>
+      </p:grpSp>
+      <p:pic>
+        <p:nvPicPr>
+          <p:cNvPr id="12" name="图片 11">
+            <a:extLst>
+              <a:ext uri="{FF2B5EF4-FFF2-40B4-BE49-F238E27FC236}">
+                <a16:creationId xmlns:a16="http://schemas.microsoft.com/office/drawing/2014/main" id="{83DC2825-0107-2E1F-06AF-5AD5ED0D420D}"/>
+              </a:ext>
+            </a:extLst>
+          </p:cNvPr>
+          <p:cNvPicPr>
+            <a:picLocks noChangeAspect="1"/>
+          </p:cNvPicPr>
+          <p:nvPr/>
+        </p:nvPicPr>
+        <p:blipFill>
+          <a:blip r:embed="rId4"/>
+          <a:stretch>
+            <a:fillRect/>
+          </a:stretch>
+        </p:blipFill>
+        <p:spPr>
+          <a:xfrm>
+            <a:off x="6749543" y="0"/>
+            <a:ext cx="6421582" cy="6858000"/>
+          </a:xfrm>
+          <a:prstGeom prst="rect">
+            <a:avLst/>
+          </a:prstGeom>
+        </p:spPr>
+      </p:pic>
+      <p:grpSp>
+        <p:nvGrpSpPr>
+          <p:cNvPr id="4" name="组合 3">
+            <a:extLst>
+              <a:ext uri="{FF2B5EF4-FFF2-40B4-BE49-F238E27FC236}">
+                <a16:creationId xmlns:a16="http://schemas.microsoft.com/office/drawing/2014/main" id="{7814559E-B2DE-D08B-D4BC-0745724ED4DA}"/>
+              </a:ext>
+            </a:extLst>
+          </p:cNvPr>
+          <p:cNvGrpSpPr/>
+          <p:nvPr/>
+        </p:nvGrpSpPr>
+        <p:grpSpPr>
+          <a:xfrm>
+            <a:off x="7787691" y="1086370"/>
+            <a:ext cx="4527373" cy="4527373"/>
+            <a:chOff x="7787691" y="1086370"/>
+            <a:chExt cx="4527373" cy="4527373"/>
+          </a:xfrm>
+        </p:grpSpPr>
+        <p:sp>
+          <p:nvSpPr>
+            <p:cNvPr id="2" name="矩形: 圆角 1">
+              <a:extLst>
+                <a:ext uri="{FF2B5EF4-FFF2-40B4-BE49-F238E27FC236}">
+                  <a16:creationId xmlns:a16="http://schemas.microsoft.com/office/drawing/2014/main" id="{26F3E23F-5EA7-5889-FFBB-EA970F583844}"/>
+                </a:ext>
+              </a:extLst>
+            </p:cNvPr>
+            <p:cNvSpPr/>
+            <p:nvPr/>
+          </p:nvSpPr>
+          <p:spPr>
+            <a:xfrm>
+              <a:off x="7787691" y="1086370"/>
+              <a:ext cx="4527373" cy="4527373"/>
+            </a:xfrm>
+            <a:prstGeom prst="roundRect">
+              <a:avLst>
+                <a:gd name="adj" fmla="val 10919"/>
+              </a:avLst>
+            </a:prstGeom>
+            <a:noFill/>
+            <a:ln w="190500">
+              <a:solidFill>
+                <a:schemeClr val="accent4"/>
+              </a:solidFill>
+            </a:ln>
+          </p:spPr>
+          <p:style>
+            <a:lnRef idx="2">
+              <a:schemeClr val="accent1">
+                <a:shade val="15000"/>
+              </a:schemeClr>
+            </a:lnRef>
+            <a:fillRef idx="1">
+              <a:schemeClr val="accent1"/>
+            </a:fillRef>
+            <a:effectRef idx="0">
+              <a:schemeClr val="accent1"/>
+            </a:effectRef>
+            <a:fontRef idx="minor">
+              <a:schemeClr val="lt1"/>
+            </a:fontRef>
+          </p:style>
+          <p:txBody>
+            <a:bodyPr rtlCol="0" anchor="ctr"/>
+            <a:lstStyle/>
+            <a:p>
+              <a:pPr algn="ctr"/>
+              <a:endParaRPr lang="zh-SG" altLang="en-US"/>
+            </a:p>
+          </p:txBody>
+        </p:sp>
+        <p:pic>
+          <p:nvPicPr>
+            <p:cNvPr id="3" name="图形 2">
+              <a:extLst>
+                <a:ext uri="{FF2B5EF4-FFF2-40B4-BE49-F238E27FC236}">
+                  <a16:creationId xmlns:a16="http://schemas.microsoft.com/office/drawing/2014/main" id="{D55A0152-B377-FED4-62E7-E0ACFB29BF3F}"/>
+                </a:ext>
+              </a:extLst>
+            </p:cNvPr>
+            <p:cNvPicPr>
+              <a:picLocks noChangeAspect="1"/>
+            </p:cNvPicPr>
+            <p:nvPr/>
+          </p:nvPicPr>
+          <p:blipFill>
+            <a:blip>
+              <a:extLst>
+                <a:ext uri="{96DAC541-7B7A-43D3-8B79-37D633B846F1}">
+                  <asvg:svgBlip xmlns:asvg="http://schemas.microsoft.com/office/drawing/2016/SVG/main" r:embed="rId5"/>
+                </a:ext>
+              </a:extLst>
+            </a:blip>
+            <a:stretch>
+              <a:fillRect/>
+            </a:stretch>
+          </p:blipFill>
+          <p:spPr>
+            <a:xfrm>
+              <a:off x="8265217" y="1563896"/>
+              <a:ext cx="3572320" cy="3572320"/>
+            </a:xfrm>
+            <a:prstGeom prst="rect">
+              <a:avLst/>
+            </a:prstGeom>
+          </p:spPr>
+        </p:pic>
+      </p:grpSp>
+      <p:sp>
+        <p:nvSpPr>
+          <p:cNvPr id="9" name="对话气泡: 圆角矩形 8">
+            <a:extLst>
+              <a:ext uri="{FF2B5EF4-FFF2-40B4-BE49-F238E27FC236}">
+                <a16:creationId xmlns:a16="http://schemas.microsoft.com/office/drawing/2014/main" id="{E520B2B4-FA0A-1F22-6877-D200B74F85B4}"/>
+              </a:ext>
+            </a:extLst>
+          </p:cNvPr>
+          <p:cNvSpPr/>
+          <p:nvPr/>
+        </p:nvSpPr>
+        <p:spPr>
+          <a:xfrm>
+            <a:off x="5735102" y="5467827"/>
+            <a:ext cx="2986392" cy="1341535"/>
+          </a:xfrm>
+          <a:prstGeom prst="wedgeRoundRectCallout">
+            <a:avLst>
+              <a:gd name="adj1" fmla="val -30930"/>
+              <a:gd name="adj2" fmla="val -67314"/>
+              <a:gd name="adj3" fmla="val 16667"/>
+            </a:avLst>
+          </a:prstGeom>
+          <a:solidFill>
+            <a:schemeClr val="bg1">
+              <a:lumMod val="95000"/>
+            </a:schemeClr>
+          </a:solidFill>
+          <a:ln>
+            <a:solidFill>
+              <a:schemeClr val="bg1">
+                <a:lumMod val="75000"/>
+              </a:schemeClr>
+            </a:solidFill>
+          </a:ln>
+        </p:spPr>
+        <p:style>
+          <a:lnRef idx="2">
+            <a:schemeClr val="accent1">
+              <a:shade val="15000"/>
+            </a:schemeClr>
+          </a:lnRef>
+          <a:fillRef idx="1">
+            <a:schemeClr val="accent1"/>
+          </a:fillRef>
+          <a:effectRef idx="0">
+            <a:schemeClr val="accent1"/>
+          </a:effectRef>
+          <a:fontRef idx="minor">
+            <a:schemeClr val="lt1"/>
+          </a:fontRef>
+        </p:style>
+        <p:txBody>
+          <a:bodyPr rtlCol="0" anchor="ctr"/>
+          <a:lstStyle/>
+          <a:p>
+            <a:pPr algn="ctr"/>
+            <a:r>
+              <a:rPr lang="zh-CN" altLang="en-US" dirty="0">
+                <a:solidFill>
+                  <a:sysClr val="windowText" lastClr="000000"/>
+                </a:solidFill>
+              </a:rPr>
+              <a:t>制作字体的是第一张幻灯片，但是发现明显比实际情况看起来宽，所以缩小到 </a:t>
+            </a:r>
+            <a:r>
+              <a:rPr lang="en-US" altLang="zh-CN" dirty="0">
+                <a:solidFill>
+                  <a:sysClr val="windowText" lastClr="000000"/>
+                </a:solidFill>
+              </a:rPr>
+              <a:t>15</a:t>
+            </a:r>
+            <a:r>
+              <a:rPr lang="zh-CN" altLang="en-US" dirty="0">
+                <a:solidFill>
+                  <a:sysClr val="windowText" lastClr="000000"/>
+                </a:solidFill>
+              </a:rPr>
+              <a:t>磅</a:t>
+            </a:r>
+            <a:endParaRPr lang="zh-SG" altLang="en-US" dirty="0">
+              <a:solidFill>
+                <a:sysClr val="windowText" lastClr="000000"/>
+              </a:solidFill>
+            </a:endParaRPr>
+          </a:p>
+        </p:txBody>
+      </p:sp>
+    </p:spTree>
+    <p:extLst>
+      <p:ext uri="{BB962C8B-B14F-4D97-AF65-F5344CB8AC3E}">
+        <p14:creationId xmlns:p14="http://schemas.microsoft.com/office/powerpoint/2010/main" val="156974974"/>
+      </p:ext>
+    </p:extLst>
+  </p:cSld>
+  <p:clrMapOvr>
+    <a:masterClrMapping/>
+  </p:clrMapOvr>
+</p:sld>
+</file>
+
 <file path=ppt/theme/theme1.xml><?xml version="1.0" encoding="utf-8"?>
 <a:theme xmlns:a="http://schemas.openxmlformats.org/drawingml/2006/main" name="Office 主题​​">
   <a:themeElements>

</xml_diff>